<commit_message>
death to if else
</commit_message>
<xml_diff>
--- a/docs/LayeredArchiecture.pptx
+++ b/docs/LayeredArchiecture.pptx
@@ -6,9 +6,10 @@
   </p:sldMasterIdLst>
   <p:sldIdLst>
     <p:sldId id="256" r:id="rId2"/>
-    <p:sldId id="258" r:id="rId3"/>
-    <p:sldId id="259" r:id="rId4"/>
-    <p:sldId id="260" r:id="rId5"/>
+    <p:sldId id="261" r:id="rId3"/>
+    <p:sldId id="258" r:id="rId4"/>
+    <p:sldId id="259" r:id="rId5"/>
+    <p:sldId id="260" r:id="rId6"/>
   </p:sldIdLst>
   <p:sldSz cx="12192000" cy="6858000"/>
   <p:notesSz cx="6858000" cy="9144000"/>
@@ -264,7 +265,7 @@
           <a:p>
             <a:fld id="{E246615E-5D88-EF43-B211-95113B4D7E53}" type="datetimeFigureOut">
               <a:rPr lang="en-US" smtClean="0"/>
-              <a:t>5/13/24</a:t>
+              <a:t>5/23/24</a:t>
             </a:fld>
             <a:endParaRPr lang="en-US"/>
           </a:p>
@@ -464,7 +465,7 @@
           <a:p>
             <a:fld id="{E246615E-5D88-EF43-B211-95113B4D7E53}" type="datetimeFigureOut">
               <a:rPr lang="en-US" smtClean="0"/>
-              <a:t>5/13/24</a:t>
+              <a:t>5/23/24</a:t>
             </a:fld>
             <a:endParaRPr lang="en-US"/>
           </a:p>
@@ -674,7 +675,7 @@
           <a:p>
             <a:fld id="{E246615E-5D88-EF43-B211-95113B4D7E53}" type="datetimeFigureOut">
               <a:rPr lang="en-US" smtClean="0"/>
-              <a:t>5/13/24</a:t>
+              <a:t>5/23/24</a:t>
             </a:fld>
             <a:endParaRPr lang="en-US"/>
           </a:p>
@@ -874,7 +875,7 @@
           <a:p>
             <a:fld id="{E246615E-5D88-EF43-B211-95113B4D7E53}" type="datetimeFigureOut">
               <a:rPr lang="en-US" smtClean="0"/>
-              <a:t>5/13/24</a:t>
+              <a:t>5/23/24</a:t>
             </a:fld>
             <a:endParaRPr lang="en-US"/>
           </a:p>
@@ -1150,7 +1151,7 @@
           <a:p>
             <a:fld id="{E246615E-5D88-EF43-B211-95113B4D7E53}" type="datetimeFigureOut">
               <a:rPr lang="en-US" smtClean="0"/>
-              <a:t>5/13/24</a:t>
+              <a:t>5/23/24</a:t>
             </a:fld>
             <a:endParaRPr lang="en-US"/>
           </a:p>
@@ -1418,7 +1419,7 @@
           <a:p>
             <a:fld id="{E246615E-5D88-EF43-B211-95113B4D7E53}" type="datetimeFigureOut">
               <a:rPr lang="en-US" smtClean="0"/>
-              <a:t>5/13/24</a:t>
+              <a:t>5/23/24</a:t>
             </a:fld>
             <a:endParaRPr lang="en-US"/>
           </a:p>
@@ -1833,7 +1834,7 @@
           <a:p>
             <a:fld id="{E246615E-5D88-EF43-B211-95113B4D7E53}" type="datetimeFigureOut">
               <a:rPr lang="en-US" smtClean="0"/>
-              <a:t>5/13/24</a:t>
+              <a:t>5/23/24</a:t>
             </a:fld>
             <a:endParaRPr lang="en-US"/>
           </a:p>
@@ -1975,7 +1976,7 @@
           <a:p>
             <a:fld id="{E246615E-5D88-EF43-B211-95113B4D7E53}" type="datetimeFigureOut">
               <a:rPr lang="en-US" smtClean="0"/>
-              <a:t>5/13/24</a:t>
+              <a:t>5/23/24</a:t>
             </a:fld>
             <a:endParaRPr lang="en-US"/>
           </a:p>
@@ -2088,7 +2089,7 @@
           <a:p>
             <a:fld id="{E246615E-5D88-EF43-B211-95113B4D7E53}" type="datetimeFigureOut">
               <a:rPr lang="en-US" smtClean="0"/>
-              <a:t>5/13/24</a:t>
+              <a:t>5/23/24</a:t>
             </a:fld>
             <a:endParaRPr lang="en-US"/>
           </a:p>
@@ -2401,7 +2402,7 @@
           <a:p>
             <a:fld id="{E246615E-5D88-EF43-B211-95113B4D7E53}" type="datetimeFigureOut">
               <a:rPr lang="en-US" smtClean="0"/>
-              <a:t>5/13/24</a:t>
+              <a:t>5/23/24</a:t>
             </a:fld>
             <a:endParaRPr lang="en-US"/>
           </a:p>
@@ -2690,7 +2691,7 @@
           <a:p>
             <a:fld id="{E246615E-5D88-EF43-B211-95113B4D7E53}" type="datetimeFigureOut">
               <a:rPr lang="en-US" smtClean="0"/>
-              <a:t>5/13/24</a:t>
+              <a:t>5/23/24</a:t>
             </a:fld>
             <a:endParaRPr lang="en-US"/>
           </a:p>
@@ -2933,7 +2934,7 @@
           <a:p>
             <a:fld id="{E246615E-5D88-EF43-B211-95113B4D7E53}" type="datetimeFigureOut">
               <a:rPr lang="en-US" smtClean="0"/>
-              <a:t>5/13/24</a:t>
+              <a:t>5/23/24</a:t>
             </a:fld>
             <a:endParaRPr lang="en-US"/>
           </a:p>
@@ -3352,10 +3353,10 @@
       </p:grpSpPr>
       <p:sp>
         <p:nvSpPr>
-          <p:cNvPr id="4" name="Rectangle 3">
-            <a:extLst>
-              <a:ext uri="{FF2B5EF4-FFF2-40B4-BE49-F238E27FC236}">
-                <a16:creationId xmlns:a16="http://schemas.microsoft.com/office/drawing/2014/main" id="{65667978-06E0-6846-46AA-59F436929672}"/>
+          <p:cNvPr id="32" name="Rectangle 31">
+            <a:extLst>
+              <a:ext uri="{FF2B5EF4-FFF2-40B4-BE49-F238E27FC236}">
+                <a16:creationId xmlns:a16="http://schemas.microsoft.com/office/drawing/2014/main" id="{C90FA319-BC3E-8E70-E5A6-255C23284AC5}"/>
               </a:ext>
             </a:extLst>
           </p:cNvPr>
@@ -3364,12 +3365,15 @@
         </p:nvSpPr>
         <p:spPr>
           <a:xfrm>
-            <a:off x="3376776" y="4258185"/>
-            <a:ext cx="1232452" cy="503582"/>
+            <a:off x="7792279" y="2855844"/>
+            <a:ext cx="4260160" cy="1908314"/>
           </a:xfrm>
           <a:prstGeom prst="rect">
             <a:avLst/>
           </a:prstGeom>
+          <a:solidFill>
+            <a:srgbClr val="FFFC00"/>
+          </a:solidFill>
         </p:spPr>
         <p:style>
           <a:lnRef idx="2">
@@ -3392,19 +3396,16 @@
           <a:lstStyle/>
           <a:p>
             <a:pPr algn="ctr"/>
-            <a:r>
-              <a:rPr lang="en-US" dirty="0"/>
-              <a:t>Capability</a:t>
-            </a:r>
-          </a:p>
-        </p:txBody>
-      </p:sp>
-      <p:sp>
-        <p:nvSpPr>
-          <p:cNvPr id="6" name="Rectangle 5">
-            <a:extLst>
-              <a:ext uri="{FF2B5EF4-FFF2-40B4-BE49-F238E27FC236}">
-                <a16:creationId xmlns:a16="http://schemas.microsoft.com/office/drawing/2014/main" id="{C64284FD-39EE-8585-4825-F6ABC99B3DC1}"/>
+            <a:endParaRPr lang="en-US"/>
+          </a:p>
+        </p:txBody>
+      </p:sp>
+      <p:sp>
+        <p:nvSpPr>
+          <p:cNvPr id="4" name="Rectangle 3">
+            <a:extLst>
+              <a:ext uri="{FF2B5EF4-FFF2-40B4-BE49-F238E27FC236}">
+                <a16:creationId xmlns:a16="http://schemas.microsoft.com/office/drawing/2014/main" id="{65667978-06E0-6846-46AA-59F436929672}"/>
               </a:ext>
             </a:extLst>
           </p:cNvPr>
@@ -3413,7 +3414,7 @@
         </p:nvSpPr>
         <p:spPr>
           <a:xfrm>
-            <a:off x="3391289" y="3620927"/>
+            <a:off x="9375499" y="4205176"/>
             <a:ext cx="1232452" cy="503582"/>
           </a:xfrm>
           <a:prstGeom prst="rect">
@@ -3443,17 +3444,17 @@
             <a:pPr algn="ctr"/>
             <a:r>
               <a:rPr lang="en-US" dirty="0"/>
-              <a:t>Service</a:t>
-            </a:r>
-          </a:p>
-        </p:txBody>
-      </p:sp>
-      <p:sp>
-        <p:nvSpPr>
-          <p:cNvPr id="7" name="Rectangle 6">
-            <a:extLst>
-              <a:ext uri="{FF2B5EF4-FFF2-40B4-BE49-F238E27FC236}">
-                <a16:creationId xmlns:a16="http://schemas.microsoft.com/office/drawing/2014/main" id="{CC0971D4-16DD-47AB-07FB-06E51990E789}"/>
+              <a:t>Capability</a:t>
+            </a:r>
+          </a:p>
+        </p:txBody>
+      </p:sp>
+      <p:sp>
+        <p:nvSpPr>
+          <p:cNvPr id="6" name="Rectangle 5">
+            <a:extLst>
+              <a:ext uri="{FF2B5EF4-FFF2-40B4-BE49-F238E27FC236}">
+                <a16:creationId xmlns:a16="http://schemas.microsoft.com/office/drawing/2014/main" id="{C64284FD-39EE-8585-4825-F6ABC99B3DC1}"/>
               </a:ext>
             </a:extLst>
           </p:cNvPr>
@@ -3462,8 +3463,8 @@
         </p:nvSpPr>
         <p:spPr>
           <a:xfrm>
-            <a:off x="1861923" y="4258185"/>
-            <a:ext cx="1378225" cy="503582"/>
+            <a:off x="9390012" y="3567918"/>
+            <a:ext cx="1232452" cy="503582"/>
           </a:xfrm>
           <a:prstGeom prst="rect">
             <a:avLst/>
@@ -3492,17 +3493,17 @@
             <a:pPr algn="ctr"/>
             <a:r>
               <a:rPr lang="en-US" dirty="0"/>
-              <a:t>Repository</a:t>
-            </a:r>
-          </a:p>
-        </p:txBody>
-      </p:sp>
-      <p:sp>
-        <p:nvSpPr>
-          <p:cNvPr id="8" name="Rectangle 7">
-            <a:extLst>
-              <a:ext uri="{FF2B5EF4-FFF2-40B4-BE49-F238E27FC236}">
-                <a16:creationId xmlns:a16="http://schemas.microsoft.com/office/drawing/2014/main" id="{4BBF3849-82F8-2640-DB9B-D07ED2A54C83}"/>
+              <a:t>Service</a:t>
+            </a:r>
+          </a:p>
+        </p:txBody>
+      </p:sp>
+      <p:sp>
+        <p:nvSpPr>
+          <p:cNvPr id="7" name="Rectangle 6">
+            <a:extLst>
+              <a:ext uri="{FF2B5EF4-FFF2-40B4-BE49-F238E27FC236}">
+                <a16:creationId xmlns:a16="http://schemas.microsoft.com/office/drawing/2014/main" id="{CC0971D4-16DD-47AB-07FB-06E51990E789}"/>
               </a:ext>
             </a:extLst>
           </p:cNvPr>
@@ -3511,8 +3512,8 @@
         </p:nvSpPr>
         <p:spPr>
           <a:xfrm>
-            <a:off x="1883717" y="2345160"/>
-            <a:ext cx="1232452" cy="503582"/>
+            <a:off x="7860646" y="4205176"/>
+            <a:ext cx="1378225" cy="503582"/>
           </a:xfrm>
           <a:prstGeom prst="rect">
             <a:avLst/>
@@ -3541,17 +3542,17 @@
             <a:pPr algn="ctr"/>
             <a:r>
               <a:rPr lang="en-US" dirty="0"/>
-              <a:t>Business Process</a:t>
-            </a:r>
-          </a:p>
-        </p:txBody>
-      </p:sp>
-      <p:sp>
-        <p:nvSpPr>
-          <p:cNvPr id="9" name="Rectangle 8">
-            <a:extLst>
-              <a:ext uri="{FF2B5EF4-FFF2-40B4-BE49-F238E27FC236}">
-                <a16:creationId xmlns:a16="http://schemas.microsoft.com/office/drawing/2014/main" id="{EE12562A-EECC-DC58-9DE8-7A314D621FE7}"/>
+              <a:t>Repository</a:t>
+            </a:r>
+          </a:p>
+        </p:txBody>
+      </p:sp>
+      <p:sp>
+        <p:nvSpPr>
+          <p:cNvPr id="8" name="Rectangle 7">
+            <a:extLst>
+              <a:ext uri="{FF2B5EF4-FFF2-40B4-BE49-F238E27FC236}">
+                <a16:creationId xmlns:a16="http://schemas.microsoft.com/office/drawing/2014/main" id="{4BBF3849-82F8-2640-DB9B-D07ED2A54C83}"/>
               </a:ext>
             </a:extLst>
           </p:cNvPr>
@@ -3560,7 +3561,7 @@
         </p:nvSpPr>
         <p:spPr>
           <a:xfrm>
-            <a:off x="3391289" y="2978427"/>
+            <a:off x="7882440" y="2292151"/>
             <a:ext cx="1232452" cy="503582"/>
           </a:xfrm>
           <a:prstGeom prst="rect">
@@ -3590,52 +3591,17 @@
             <a:pPr algn="ctr"/>
             <a:r>
               <a:rPr lang="en-US" dirty="0"/>
-              <a:t>Controller</a:t>
-            </a:r>
-          </a:p>
-        </p:txBody>
-      </p:sp>
-      <p:sp>
-        <p:nvSpPr>
-          <p:cNvPr id="11" name="TextBox 10">
-            <a:extLst>
-              <a:ext uri="{FF2B5EF4-FFF2-40B4-BE49-F238E27FC236}">
-                <a16:creationId xmlns:a16="http://schemas.microsoft.com/office/drawing/2014/main" id="{898A7369-50C6-E741-43BD-72492E7D7424}"/>
-              </a:ext>
-            </a:extLst>
-          </p:cNvPr>
-          <p:cNvSpPr txBox="1"/>
-          <p:nvPr/>
-        </p:nvSpPr>
-        <p:spPr>
-          <a:xfrm>
-            <a:off x="397611" y="5649458"/>
-            <a:ext cx="1243930" cy="307777"/>
-          </a:xfrm>
-          <a:prstGeom prst="rect">
-            <a:avLst/>
-          </a:prstGeom>
-          <a:noFill/>
-        </p:spPr>
-        <p:txBody>
-          <a:bodyPr wrap="square" rtlCol="0">
-            <a:spAutoFit/>
-          </a:bodyPr>
-          <a:lstStyle/>
-          <a:p>
-            <a:r>
-              <a:rPr lang="en-US" sz="1400" dirty="0"/>
-              <a:t>runtime layer </a:t>
-            </a:r>
-          </a:p>
-        </p:txBody>
-      </p:sp>
-      <p:sp>
-        <p:nvSpPr>
-          <p:cNvPr id="12" name="Rectangle 11">
-            <a:extLst>
-              <a:ext uri="{FF2B5EF4-FFF2-40B4-BE49-F238E27FC236}">
-                <a16:creationId xmlns:a16="http://schemas.microsoft.com/office/drawing/2014/main" id="{E5746671-07D3-6332-1172-9EC79C894E4C}"/>
+              <a:t>Business Process</a:t>
+            </a:r>
+          </a:p>
+        </p:txBody>
+      </p:sp>
+      <p:sp>
+        <p:nvSpPr>
+          <p:cNvPr id="9" name="Rectangle 8">
+            <a:extLst>
+              <a:ext uri="{FF2B5EF4-FFF2-40B4-BE49-F238E27FC236}">
+                <a16:creationId xmlns:a16="http://schemas.microsoft.com/office/drawing/2014/main" id="{EE12562A-EECC-DC58-9DE8-7A314D621FE7}"/>
               </a:ext>
             </a:extLst>
           </p:cNvPr>
@@ -3644,7 +3610,7 @@
         </p:nvSpPr>
         <p:spPr>
           <a:xfrm>
-            <a:off x="3362887" y="4887656"/>
+            <a:off x="9390012" y="2925418"/>
             <a:ext cx="1232452" cy="503582"/>
           </a:xfrm>
           <a:prstGeom prst="rect">
@@ -3673,182 +3639,18 @@
           <a:p>
             <a:pPr algn="ctr"/>
             <a:r>
-              <a:rPr lang="en-US" sz="1200" dirty="0"/>
-              <a:t>Included Dependencies</a:t>
-            </a:r>
-          </a:p>
-        </p:txBody>
-      </p:sp>
-      <p:sp>
-        <p:nvSpPr>
-          <p:cNvPr id="13" name="TextBox 12">
-            <a:extLst>
-              <a:ext uri="{FF2B5EF4-FFF2-40B4-BE49-F238E27FC236}">
-                <a16:creationId xmlns:a16="http://schemas.microsoft.com/office/drawing/2014/main" id="{6D79A8F0-0084-290D-584F-672D71C99F6E}"/>
-              </a:ext>
-            </a:extLst>
-          </p:cNvPr>
-          <p:cNvSpPr txBox="1"/>
-          <p:nvPr/>
-        </p:nvSpPr>
-        <p:spPr>
-          <a:xfrm>
-            <a:off x="420397" y="3114693"/>
-            <a:ext cx="1251818" cy="307777"/>
-          </a:xfrm>
-          <a:prstGeom prst="rect">
-            <a:avLst/>
-          </a:prstGeom>
-          <a:noFill/>
-        </p:spPr>
-        <p:txBody>
-          <a:bodyPr wrap="square" rtlCol="0">
-            <a:spAutoFit/>
-          </a:bodyPr>
-          <a:lstStyle/>
-          <a:p>
-            <a:r>
-              <a:rPr lang="en-US" sz="1400" dirty="0"/>
-              <a:t>protocol layer</a:t>
-            </a:r>
-          </a:p>
-        </p:txBody>
-      </p:sp>
-      <p:sp>
-        <p:nvSpPr>
-          <p:cNvPr id="14" name="TextBox 13">
-            <a:extLst>
-              <a:ext uri="{FF2B5EF4-FFF2-40B4-BE49-F238E27FC236}">
-                <a16:creationId xmlns:a16="http://schemas.microsoft.com/office/drawing/2014/main" id="{A0FF231E-9ADF-3DBD-97A5-64F7469CFD60}"/>
-              </a:ext>
-            </a:extLst>
-          </p:cNvPr>
-          <p:cNvSpPr txBox="1"/>
-          <p:nvPr/>
-        </p:nvSpPr>
-        <p:spPr>
-          <a:xfrm>
-            <a:off x="305945" y="3824845"/>
-            <a:ext cx="2893740" cy="307777"/>
-          </a:xfrm>
-          <a:prstGeom prst="rect">
-            <a:avLst/>
-          </a:prstGeom>
-          <a:noFill/>
-        </p:spPr>
-        <p:txBody>
-          <a:bodyPr wrap="square" rtlCol="0">
-            <a:spAutoFit/>
-          </a:bodyPr>
-          <a:lstStyle/>
-          <a:p>
-            <a:r>
-              <a:rPr lang="en-US" sz="1400" dirty="0"/>
-              <a:t>Domain Layer – business decisions</a:t>
-            </a:r>
-          </a:p>
-        </p:txBody>
-      </p:sp>
-      <p:sp>
-        <p:nvSpPr>
-          <p:cNvPr id="16" name="TextBox 15">
-            <a:extLst>
-              <a:ext uri="{FF2B5EF4-FFF2-40B4-BE49-F238E27FC236}">
-                <a16:creationId xmlns:a16="http://schemas.microsoft.com/office/drawing/2014/main" id="{95691C88-6773-EF9B-6D49-44C5388C638D}"/>
-              </a:ext>
-            </a:extLst>
-          </p:cNvPr>
-          <p:cNvSpPr txBox="1"/>
-          <p:nvPr/>
-        </p:nvSpPr>
-        <p:spPr>
-          <a:xfrm>
-            <a:off x="575202" y="537823"/>
-            <a:ext cx="6096000" cy="646331"/>
-          </a:xfrm>
-          <a:prstGeom prst="rect">
-            <a:avLst/>
-          </a:prstGeom>
-          <a:noFill/>
-        </p:spPr>
-        <p:txBody>
-          <a:bodyPr wrap="square">
-            <a:spAutoFit/>
-          </a:bodyPr>
-          <a:lstStyle/>
-          <a:p>
-            <a:r>
               <a:rPr lang="en-US" dirty="0"/>
-              <a:t>https://</a:t>
-            </a:r>
-            <a:r>
-              <a:rPr lang="en-US" dirty="0" err="1"/>
-              <a:t>www.linkedin.com</a:t>
-            </a:r>
-            <a:r>
-              <a:rPr lang="en-US" dirty="0"/>
-              <a:t>/pulse/service-vs-capability-process-</a:t>
-            </a:r>
-            <a:r>
-              <a:rPr lang="en-US" dirty="0" err="1"/>
-              <a:t>daniel</a:t>
-            </a:r>
-            <a:r>
-              <a:rPr lang="en-US" dirty="0"/>
-              <a:t>-</a:t>
-            </a:r>
-            <a:r>
-              <a:rPr lang="en-US" dirty="0" err="1"/>
-              <a:t>dekkers</a:t>
-            </a:r>
-            <a:r>
-              <a:rPr lang="en-US" dirty="0"/>
-              <a:t>/</a:t>
-            </a:r>
-          </a:p>
-        </p:txBody>
-      </p:sp>
-      <p:sp>
-        <p:nvSpPr>
-          <p:cNvPr id="17" name="TextBox 16">
-            <a:extLst>
-              <a:ext uri="{FF2B5EF4-FFF2-40B4-BE49-F238E27FC236}">
-                <a16:creationId xmlns:a16="http://schemas.microsoft.com/office/drawing/2014/main" id="{CB6D8983-A086-61D7-52A5-12082839C8F3}"/>
-              </a:ext>
-            </a:extLst>
-          </p:cNvPr>
-          <p:cNvSpPr txBox="1"/>
-          <p:nvPr/>
-        </p:nvSpPr>
-        <p:spPr>
-          <a:xfrm>
-            <a:off x="2091029" y="3429000"/>
-            <a:ext cx="1291123" cy="307777"/>
-          </a:xfrm>
-          <a:prstGeom prst="rect">
-            <a:avLst/>
-          </a:prstGeom>
-          <a:noFill/>
-        </p:spPr>
-        <p:txBody>
-          <a:bodyPr wrap="square" rtlCol="0">
-            <a:spAutoFit/>
-          </a:bodyPr>
-          <a:lstStyle/>
-          <a:p>
-            <a:r>
-              <a:rPr lang="en-US" sz="1400" dirty="0"/>
-              <a:t>Interface layer</a:t>
-            </a:r>
-          </a:p>
-        </p:txBody>
-      </p:sp>
-      <p:sp>
-        <p:nvSpPr>
-          <p:cNvPr id="18" name="Rectangle 17">
-            <a:extLst>
-              <a:ext uri="{FF2B5EF4-FFF2-40B4-BE49-F238E27FC236}">
-                <a16:creationId xmlns:a16="http://schemas.microsoft.com/office/drawing/2014/main" id="{6D5C7269-2C2B-EADE-CFC2-B957A7415972}"/>
+              <a:t>Controller</a:t>
+            </a:r>
+          </a:p>
+        </p:txBody>
+      </p:sp>
+      <p:sp>
+        <p:nvSpPr>
+          <p:cNvPr id="12" name="Rectangle 11">
+            <a:extLst>
+              <a:ext uri="{FF2B5EF4-FFF2-40B4-BE49-F238E27FC236}">
+                <a16:creationId xmlns:a16="http://schemas.microsoft.com/office/drawing/2014/main" id="{E5746671-07D3-6332-1172-9EC79C894E4C}"/>
               </a:ext>
             </a:extLst>
           </p:cNvPr>
@@ -3857,7 +3659,7 @@
         </p:nvSpPr>
         <p:spPr>
           <a:xfrm>
-            <a:off x="3362887" y="5543084"/>
+            <a:off x="9361610" y="4834647"/>
             <a:ext cx="1232452" cy="503582"/>
           </a:xfrm>
           <a:prstGeom prst="rect">
@@ -3886,18 +3688,18 @@
           <a:p>
             <a:pPr algn="ctr"/>
             <a:r>
-              <a:rPr lang="en-US" dirty="0"/>
-              <a:t>Java</a:t>
-            </a:r>
-          </a:p>
-        </p:txBody>
-      </p:sp>
-      <p:sp>
-        <p:nvSpPr>
-          <p:cNvPr id="19" name="TextBox 18">
-            <a:extLst>
-              <a:ext uri="{FF2B5EF4-FFF2-40B4-BE49-F238E27FC236}">
-                <a16:creationId xmlns:a16="http://schemas.microsoft.com/office/drawing/2014/main" id="{7916A07C-C969-1B93-2C7C-9D0F0B0667DE}"/>
+              <a:rPr lang="en-US" sz="1300" dirty="0"/>
+              <a:t>Dependencies</a:t>
+            </a:r>
+          </a:p>
+        </p:txBody>
+      </p:sp>
+      <p:sp>
+        <p:nvSpPr>
+          <p:cNvPr id="13" name="TextBox 12">
+            <a:extLst>
+              <a:ext uri="{FF2B5EF4-FFF2-40B4-BE49-F238E27FC236}">
+                <a16:creationId xmlns:a16="http://schemas.microsoft.com/office/drawing/2014/main" id="{6D79A8F0-0084-290D-584F-672D71C99F6E}"/>
               </a:ext>
             </a:extLst>
           </p:cNvPr>
@@ -3906,8 +3708,8 @@
         </p:nvSpPr>
         <p:spPr>
           <a:xfrm>
-            <a:off x="397611" y="5025762"/>
-            <a:ext cx="1464312" cy="307777"/>
+            <a:off x="715746" y="3019562"/>
+            <a:ext cx="1251818" cy="307777"/>
           </a:xfrm>
           <a:prstGeom prst="rect">
             <a:avLst/>
@@ -3922,17 +3724,111 @@
           <a:p>
             <a:r>
               <a:rPr lang="en-US" sz="1400" dirty="0"/>
-              <a:t>framework layer</a:t>
-            </a:r>
-          </a:p>
-        </p:txBody>
-      </p:sp>
-      <p:sp>
-        <p:nvSpPr>
-          <p:cNvPr id="20" name="Rectangle 19">
-            <a:extLst>
-              <a:ext uri="{FF2B5EF4-FFF2-40B4-BE49-F238E27FC236}">
-                <a16:creationId xmlns:a16="http://schemas.microsoft.com/office/drawing/2014/main" id="{F1DCB4DF-03F4-8903-75DC-2A7AA138EAF2}"/>
+              <a:t>protocol layer</a:t>
+            </a:r>
+          </a:p>
+        </p:txBody>
+      </p:sp>
+      <p:sp>
+        <p:nvSpPr>
+          <p:cNvPr id="14" name="TextBox 13">
+            <a:extLst>
+              <a:ext uri="{FF2B5EF4-FFF2-40B4-BE49-F238E27FC236}">
+                <a16:creationId xmlns:a16="http://schemas.microsoft.com/office/drawing/2014/main" id="{A0FF231E-9ADF-3DBD-97A5-64F7469CFD60}"/>
+              </a:ext>
+            </a:extLst>
+          </p:cNvPr>
+          <p:cNvSpPr txBox="1"/>
+          <p:nvPr/>
+        </p:nvSpPr>
+        <p:spPr>
+          <a:xfrm>
+            <a:off x="973820" y="5659212"/>
+            <a:ext cx="1251818" cy="307777"/>
+          </a:xfrm>
+          <a:prstGeom prst="rect">
+            <a:avLst/>
+          </a:prstGeom>
+          <a:noFill/>
+        </p:spPr>
+        <p:txBody>
+          <a:bodyPr wrap="square" rtlCol="0">
+            <a:spAutoFit/>
+          </a:bodyPr>
+          <a:lstStyle/>
+          <a:p>
+            <a:r>
+              <a:rPr lang="en-US" sz="1400" dirty="0"/>
+              <a:t>Domain Layer</a:t>
+            </a:r>
+          </a:p>
+        </p:txBody>
+      </p:sp>
+      <p:sp>
+        <p:nvSpPr>
+          <p:cNvPr id="16" name="TextBox 15">
+            <a:extLst>
+              <a:ext uri="{FF2B5EF4-FFF2-40B4-BE49-F238E27FC236}">
+                <a16:creationId xmlns:a16="http://schemas.microsoft.com/office/drawing/2014/main" id="{95691C88-6773-EF9B-6D49-44C5388C638D}"/>
+              </a:ext>
+            </a:extLst>
+          </p:cNvPr>
+          <p:cNvSpPr txBox="1"/>
+          <p:nvPr/>
+        </p:nvSpPr>
+        <p:spPr>
+          <a:xfrm>
+            <a:off x="234734" y="318225"/>
+            <a:ext cx="6096000" cy="646331"/>
+          </a:xfrm>
+          <a:prstGeom prst="rect">
+            <a:avLst/>
+          </a:prstGeom>
+          <a:noFill/>
+        </p:spPr>
+        <p:txBody>
+          <a:bodyPr wrap="square">
+            <a:spAutoFit/>
+          </a:bodyPr>
+          <a:lstStyle/>
+          <a:p>
+            <a:r>
+              <a:rPr lang="en-US" dirty="0"/>
+              <a:t>https://</a:t>
+            </a:r>
+            <a:r>
+              <a:rPr lang="en-US" dirty="0" err="1"/>
+              <a:t>www.linkedin.com</a:t>
+            </a:r>
+            <a:r>
+              <a:rPr lang="en-US" dirty="0"/>
+              <a:t>/pulse/service-vs-capability-process-</a:t>
+            </a:r>
+            <a:r>
+              <a:rPr lang="en-US" dirty="0" err="1"/>
+              <a:t>daniel</a:t>
+            </a:r>
+            <a:r>
+              <a:rPr lang="en-US" dirty="0"/>
+              <a:t>-</a:t>
+            </a:r>
+            <a:r>
+              <a:rPr lang="en-US" dirty="0" err="1"/>
+              <a:t>dekkers</a:t>
+            </a:r>
+            <a:r>
+              <a:rPr lang="en-US" dirty="0"/>
+              <a:t>/</a:t>
+            </a:r>
+          </a:p>
+        </p:txBody>
+      </p:sp>
+      <p:sp>
+        <p:nvSpPr>
+          <p:cNvPr id="18" name="Rectangle 17">
+            <a:extLst>
+              <a:ext uri="{FF2B5EF4-FFF2-40B4-BE49-F238E27FC236}">
+                <a16:creationId xmlns:a16="http://schemas.microsoft.com/office/drawing/2014/main" id="{6D5C7269-2C2B-EADE-CFC2-B957A7415972}"/>
               </a:ext>
             </a:extLst>
           </p:cNvPr>
@@ -3941,7 +3837,7 @@
         </p:nvSpPr>
         <p:spPr>
           <a:xfrm>
-            <a:off x="3362887" y="6198512"/>
+            <a:off x="9361610" y="5490075"/>
             <a:ext cx="1232452" cy="503582"/>
           </a:xfrm>
           <a:prstGeom prst="rect">
@@ -3971,52 +3867,17 @@
             <a:pPr algn="ctr"/>
             <a:r>
               <a:rPr lang="en-US" dirty="0"/>
-              <a:t>Cloud</a:t>
-            </a:r>
-          </a:p>
-        </p:txBody>
-      </p:sp>
-      <p:sp>
-        <p:nvSpPr>
-          <p:cNvPr id="21" name="TextBox 20">
-            <a:extLst>
-              <a:ext uri="{FF2B5EF4-FFF2-40B4-BE49-F238E27FC236}">
-                <a16:creationId xmlns:a16="http://schemas.microsoft.com/office/drawing/2014/main" id="{4FE117BE-6BFC-13F6-6E57-C6F668EF7E5A}"/>
-              </a:ext>
-            </a:extLst>
-          </p:cNvPr>
-          <p:cNvSpPr txBox="1"/>
-          <p:nvPr/>
-        </p:nvSpPr>
-        <p:spPr>
-          <a:xfrm>
-            <a:off x="420397" y="6216606"/>
-            <a:ext cx="1656736" cy="307777"/>
-          </a:xfrm>
-          <a:prstGeom prst="rect">
-            <a:avLst/>
-          </a:prstGeom>
-          <a:noFill/>
-        </p:spPr>
-        <p:txBody>
-          <a:bodyPr wrap="square" rtlCol="0">
-            <a:spAutoFit/>
-          </a:bodyPr>
-          <a:lstStyle/>
-          <a:p>
-            <a:r>
-              <a:rPr lang="en-US" sz="1400" dirty="0"/>
-              <a:t>Infrastructure layer</a:t>
-            </a:r>
-          </a:p>
-        </p:txBody>
-      </p:sp>
-      <p:sp>
-        <p:nvSpPr>
-          <p:cNvPr id="22" name="Rectangle 21">
-            <a:extLst>
-              <a:ext uri="{FF2B5EF4-FFF2-40B4-BE49-F238E27FC236}">
-                <a16:creationId xmlns:a16="http://schemas.microsoft.com/office/drawing/2014/main" id="{1E2FBBE0-796B-8B39-6B5E-46DC118915F0}"/>
+              <a:t>Java</a:t>
+            </a:r>
+          </a:p>
+        </p:txBody>
+      </p:sp>
+      <p:sp>
+        <p:nvSpPr>
+          <p:cNvPr id="20" name="Rectangle 19">
+            <a:extLst>
+              <a:ext uri="{FF2B5EF4-FFF2-40B4-BE49-F238E27FC236}">
+                <a16:creationId xmlns:a16="http://schemas.microsoft.com/office/drawing/2014/main" id="{F1DCB4DF-03F4-8903-75DC-2A7AA138EAF2}"/>
               </a:ext>
             </a:extLst>
           </p:cNvPr>
@@ -4025,7 +3886,7 @@
         </p:nvSpPr>
         <p:spPr>
           <a:xfrm>
-            <a:off x="4745856" y="4258185"/>
+            <a:off x="9361610" y="6145503"/>
             <a:ext cx="1232452" cy="503582"/>
           </a:xfrm>
           <a:prstGeom prst="rect">
@@ -4055,87 +3916,17 @@
             <a:pPr algn="ctr"/>
             <a:r>
               <a:rPr lang="en-US" dirty="0"/>
-              <a:t>Entity</a:t>
-            </a:r>
-          </a:p>
-        </p:txBody>
-      </p:sp>
-      <p:sp>
-        <p:nvSpPr>
-          <p:cNvPr id="25" name="TextBox 24">
-            <a:extLst>
-              <a:ext uri="{FF2B5EF4-FFF2-40B4-BE49-F238E27FC236}">
-                <a16:creationId xmlns:a16="http://schemas.microsoft.com/office/drawing/2014/main" id="{3EB0C19F-AAB3-EE6C-7F47-BD173E664160}"/>
-              </a:ext>
-            </a:extLst>
-          </p:cNvPr>
-          <p:cNvSpPr txBox="1"/>
-          <p:nvPr/>
-        </p:nvSpPr>
-        <p:spPr>
-          <a:xfrm>
-            <a:off x="8138059" y="2387282"/>
-            <a:ext cx="803425" cy="307777"/>
-          </a:xfrm>
-          <a:prstGeom prst="rect">
-            <a:avLst/>
-          </a:prstGeom>
-          <a:noFill/>
-        </p:spPr>
-        <p:txBody>
-          <a:bodyPr wrap="square" rtlCol="0">
-            <a:spAutoFit/>
-          </a:bodyPr>
-          <a:lstStyle/>
-          <a:p>
-            <a:r>
-              <a:rPr lang="en-US" sz="1400" dirty="0"/>
-              <a:t>security</a:t>
-            </a:r>
-          </a:p>
-        </p:txBody>
-      </p:sp>
-      <p:sp>
-        <p:nvSpPr>
-          <p:cNvPr id="26" name="TextBox 25">
-            <a:extLst>
-              <a:ext uri="{FF2B5EF4-FFF2-40B4-BE49-F238E27FC236}">
-                <a16:creationId xmlns:a16="http://schemas.microsoft.com/office/drawing/2014/main" id="{92D03459-4E1A-7164-77C7-AC295C3D995E}"/>
-              </a:ext>
-            </a:extLst>
-          </p:cNvPr>
-          <p:cNvSpPr txBox="1"/>
-          <p:nvPr/>
-        </p:nvSpPr>
-        <p:spPr>
-          <a:xfrm>
-            <a:off x="7031593" y="2968371"/>
-            <a:ext cx="2216706" cy="523220"/>
-          </a:xfrm>
-          <a:prstGeom prst="rect">
-            <a:avLst/>
-          </a:prstGeom>
-          <a:noFill/>
-        </p:spPr>
-        <p:txBody>
-          <a:bodyPr wrap="square" rtlCol="0">
-            <a:spAutoFit/>
-          </a:bodyPr>
-          <a:lstStyle/>
-          <a:p>
-            <a:r>
-              <a:rPr lang="en-US" sz="1400" dirty="0"/>
-              <a:t>Secure the protocol layer, in HTTP, correct headers,</a:t>
-            </a:r>
-          </a:p>
-        </p:txBody>
-      </p:sp>
-      <p:sp>
-        <p:nvSpPr>
-          <p:cNvPr id="27" name="Rectangle 26">
-            <a:extLst>
-              <a:ext uri="{FF2B5EF4-FFF2-40B4-BE49-F238E27FC236}">
-                <a16:creationId xmlns:a16="http://schemas.microsoft.com/office/drawing/2014/main" id="{20811850-1BCD-8CC8-23B0-65E362ADCA19}"/>
+              <a:t>Cloud</a:t>
+            </a:r>
+          </a:p>
+        </p:txBody>
+      </p:sp>
+      <p:sp>
+        <p:nvSpPr>
+          <p:cNvPr id="22" name="Rectangle 21">
+            <a:extLst>
+              <a:ext uri="{FF2B5EF4-FFF2-40B4-BE49-F238E27FC236}">
+                <a16:creationId xmlns:a16="http://schemas.microsoft.com/office/drawing/2014/main" id="{1E2FBBE0-796B-8B39-6B5E-46DC118915F0}"/>
               </a:ext>
             </a:extLst>
           </p:cNvPr>
@@ -4144,7 +3935,7 @@
         </p:nvSpPr>
         <p:spPr>
           <a:xfrm>
-            <a:off x="3376776" y="2345160"/>
+            <a:off x="10744579" y="4205176"/>
             <a:ext cx="1232452" cy="503582"/>
           </a:xfrm>
           <a:prstGeom prst="rect">
@@ -4174,17 +3965,17 @@
             <a:pPr algn="ctr"/>
             <a:r>
               <a:rPr lang="en-US" dirty="0"/>
-              <a:t>User</a:t>
-            </a:r>
-          </a:p>
-        </p:txBody>
-      </p:sp>
-      <p:sp>
-        <p:nvSpPr>
-          <p:cNvPr id="28" name="Rectangle 27">
-            <a:extLst>
-              <a:ext uri="{FF2B5EF4-FFF2-40B4-BE49-F238E27FC236}">
-                <a16:creationId xmlns:a16="http://schemas.microsoft.com/office/drawing/2014/main" id="{9587F788-0CDD-7151-2E57-0F3E0CE11981}"/>
+              <a:t>Entity</a:t>
+            </a:r>
+          </a:p>
+        </p:txBody>
+      </p:sp>
+      <p:sp>
+        <p:nvSpPr>
+          <p:cNvPr id="27" name="Rectangle 26">
+            <a:extLst>
+              <a:ext uri="{FF2B5EF4-FFF2-40B4-BE49-F238E27FC236}">
+                <a16:creationId xmlns:a16="http://schemas.microsoft.com/office/drawing/2014/main" id="{20811850-1BCD-8CC8-23B0-65E362ADCA19}"/>
               </a:ext>
             </a:extLst>
           </p:cNvPr>
@@ -4193,7 +3984,7 @@
         </p:nvSpPr>
         <p:spPr>
           <a:xfrm>
-            <a:off x="4821263" y="2345160"/>
+            <a:off x="9375499" y="2292151"/>
             <a:ext cx="1232452" cy="503582"/>
           </a:xfrm>
           <a:prstGeom prst="rect">
@@ -4223,192 +4014,17 @@
             <a:pPr algn="ctr"/>
             <a:r>
               <a:rPr lang="en-US" dirty="0"/>
-              <a:t>B2B</a:t>
-            </a:r>
-          </a:p>
-        </p:txBody>
-      </p:sp>
-      <p:sp>
-        <p:nvSpPr>
-          <p:cNvPr id="33" name="TextBox 32">
-            <a:extLst>
-              <a:ext uri="{FF2B5EF4-FFF2-40B4-BE49-F238E27FC236}">
-                <a16:creationId xmlns:a16="http://schemas.microsoft.com/office/drawing/2014/main" id="{A5BAD326-2948-DEC7-9000-75A06977D90F}"/>
-              </a:ext>
-            </a:extLst>
-          </p:cNvPr>
-          <p:cNvSpPr txBox="1"/>
-          <p:nvPr/>
-        </p:nvSpPr>
-        <p:spPr>
-          <a:xfrm>
-            <a:off x="7027819" y="3658731"/>
-            <a:ext cx="2220480" cy="307777"/>
-          </a:xfrm>
-          <a:prstGeom prst="rect">
-            <a:avLst/>
-          </a:prstGeom>
-          <a:noFill/>
-        </p:spPr>
-        <p:txBody>
-          <a:bodyPr wrap="square" rtlCol="0">
-            <a:spAutoFit/>
-          </a:bodyPr>
-          <a:lstStyle/>
-          <a:p>
-            <a:r>
-              <a:rPr lang="en-US" sz="1400" dirty="0"/>
-              <a:t>Business permission rules</a:t>
-            </a:r>
-          </a:p>
-        </p:txBody>
-      </p:sp>
-      <p:sp>
-        <p:nvSpPr>
-          <p:cNvPr id="34" name="TextBox 33">
-            <a:extLst>
-              <a:ext uri="{FF2B5EF4-FFF2-40B4-BE49-F238E27FC236}">
-                <a16:creationId xmlns:a16="http://schemas.microsoft.com/office/drawing/2014/main" id="{FBDA57EF-A160-4714-BBE4-33BDD34EE3B0}"/>
-              </a:ext>
-            </a:extLst>
-          </p:cNvPr>
-          <p:cNvSpPr txBox="1"/>
-          <p:nvPr/>
-        </p:nvSpPr>
-        <p:spPr>
-          <a:xfrm>
-            <a:off x="7110184" y="4479224"/>
-            <a:ext cx="2220480" cy="307777"/>
-          </a:xfrm>
-          <a:prstGeom prst="rect">
-            <a:avLst/>
-          </a:prstGeom>
-          <a:noFill/>
-        </p:spPr>
-        <p:txBody>
-          <a:bodyPr wrap="square" rtlCol="0">
-            <a:spAutoFit/>
-          </a:bodyPr>
-          <a:lstStyle/>
-          <a:p>
-            <a:r>
-              <a:rPr lang="en-US" sz="1400" dirty="0"/>
-              <a:t>Business permission rules</a:t>
-            </a:r>
-          </a:p>
-        </p:txBody>
-      </p:sp>
-      <p:sp>
-        <p:nvSpPr>
-          <p:cNvPr id="35" name="TextBox 34">
-            <a:extLst>
-              <a:ext uri="{FF2B5EF4-FFF2-40B4-BE49-F238E27FC236}">
-                <a16:creationId xmlns:a16="http://schemas.microsoft.com/office/drawing/2014/main" id="{C3D6DDC6-8047-F804-1823-2B40B1782DA8}"/>
-              </a:ext>
-            </a:extLst>
-          </p:cNvPr>
-          <p:cNvSpPr txBox="1"/>
-          <p:nvPr/>
-        </p:nvSpPr>
-        <p:spPr>
-          <a:xfrm>
-            <a:off x="7100706" y="5607496"/>
-            <a:ext cx="1851148" cy="307777"/>
-          </a:xfrm>
-          <a:prstGeom prst="rect">
-            <a:avLst/>
-          </a:prstGeom>
-          <a:noFill/>
-        </p:spPr>
-        <p:txBody>
-          <a:bodyPr wrap="square" rtlCol="0">
-            <a:spAutoFit/>
-          </a:bodyPr>
-          <a:lstStyle/>
-          <a:p>
-            <a:r>
-              <a:rPr lang="en-US" sz="1400" dirty="0"/>
-              <a:t>Keep Java Up-to-Date</a:t>
-            </a:r>
-          </a:p>
-        </p:txBody>
-      </p:sp>
-      <p:sp>
-        <p:nvSpPr>
-          <p:cNvPr id="36" name="TextBox 35">
-            <a:extLst>
-              <a:ext uri="{FF2B5EF4-FFF2-40B4-BE49-F238E27FC236}">
-                <a16:creationId xmlns:a16="http://schemas.microsoft.com/office/drawing/2014/main" id="{19773ED0-8198-C142-3023-3CD0BA0AE966}"/>
-              </a:ext>
-            </a:extLst>
-          </p:cNvPr>
-          <p:cNvSpPr txBox="1"/>
-          <p:nvPr/>
-        </p:nvSpPr>
-        <p:spPr>
-          <a:xfrm>
-            <a:off x="7160341" y="5031488"/>
-            <a:ext cx="1960921" cy="307777"/>
-          </a:xfrm>
-          <a:prstGeom prst="rect">
-            <a:avLst/>
-          </a:prstGeom>
-          <a:noFill/>
-        </p:spPr>
-        <p:txBody>
-          <a:bodyPr wrap="square" rtlCol="0">
-            <a:spAutoFit/>
-          </a:bodyPr>
-          <a:lstStyle/>
-          <a:p>
-            <a:r>
-              <a:rPr lang="en-US" sz="1400" dirty="0"/>
-              <a:t>Dependency Scanning</a:t>
-            </a:r>
-          </a:p>
-        </p:txBody>
-      </p:sp>
-      <p:sp>
-        <p:nvSpPr>
-          <p:cNvPr id="37" name="TextBox 36">
-            <a:extLst>
-              <a:ext uri="{FF2B5EF4-FFF2-40B4-BE49-F238E27FC236}">
-                <a16:creationId xmlns:a16="http://schemas.microsoft.com/office/drawing/2014/main" id="{4F3AC44C-4383-1E32-1798-CE78AE5369C0}"/>
-              </a:ext>
-            </a:extLst>
-          </p:cNvPr>
-          <p:cNvSpPr txBox="1"/>
-          <p:nvPr/>
-        </p:nvSpPr>
-        <p:spPr>
-          <a:xfrm>
-            <a:off x="7027819" y="6183504"/>
-            <a:ext cx="1327608" cy="307777"/>
-          </a:xfrm>
-          <a:prstGeom prst="rect">
-            <a:avLst/>
-          </a:prstGeom>
-          <a:noFill/>
-        </p:spPr>
-        <p:txBody>
-          <a:bodyPr wrap="square" rtlCol="0">
-            <a:spAutoFit/>
-          </a:bodyPr>
-          <a:lstStyle/>
-          <a:p>
-            <a:r>
-              <a:rPr lang="en-US" sz="1400" dirty="0"/>
-              <a:t>Cloud Security</a:t>
-            </a:r>
-          </a:p>
-        </p:txBody>
-      </p:sp>
-      <p:sp>
-        <p:nvSpPr>
-          <p:cNvPr id="39" name="Rectangle 38">
-            <a:extLst>
-              <a:ext uri="{FF2B5EF4-FFF2-40B4-BE49-F238E27FC236}">
-                <a16:creationId xmlns:a16="http://schemas.microsoft.com/office/drawing/2014/main" id="{2622D0A1-D52D-9619-BA27-76EBF485B89B}"/>
+              <a:t>User</a:t>
+            </a:r>
+          </a:p>
+        </p:txBody>
+      </p:sp>
+      <p:sp>
+        <p:nvSpPr>
+          <p:cNvPr id="28" name="Rectangle 27">
+            <a:extLst>
+              <a:ext uri="{FF2B5EF4-FFF2-40B4-BE49-F238E27FC236}">
+                <a16:creationId xmlns:a16="http://schemas.microsoft.com/office/drawing/2014/main" id="{9587F788-0CDD-7151-2E57-0F3E0CE11981}"/>
               </a:ext>
             </a:extLst>
           </p:cNvPr>
@@ -4417,8 +4033,8 @@
         </p:nvSpPr>
         <p:spPr>
           <a:xfrm>
-            <a:off x="9330664" y="2817114"/>
-            <a:ext cx="2458280" cy="1839326"/>
+            <a:off x="10819986" y="2292151"/>
+            <a:ext cx="1232452" cy="503582"/>
           </a:xfrm>
           <a:prstGeom prst="rect">
             <a:avLst/>
@@ -4447,7 +4063,7 @@
             <a:pPr algn="ctr"/>
             <a:r>
               <a:rPr lang="en-US" dirty="0"/>
-              <a:t>code scanning</a:t>
+              <a:t>B2B</a:t>
             </a:r>
           </a:p>
         </p:txBody>
@@ -4466,7 +4082,7 @@
         </p:nvSpPr>
         <p:spPr>
           <a:xfrm>
-            <a:off x="420397" y="2387282"/>
+            <a:off x="828027" y="2298676"/>
             <a:ext cx="1251818" cy="307777"/>
           </a:xfrm>
           <a:prstGeom prst="rect">
@@ -4489,10 +4105,10 @@
       </p:sp>
       <p:sp>
         <p:nvSpPr>
-          <p:cNvPr id="42" name="TextBox 41">
-            <a:extLst>
-              <a:ext uri="{FF2B5EF4-FFF2-40B4-BE49-F238E27FC236}">
-                <a16:creationId xmlns:a16="http://schemas.microsoft.com/office/drawing/2014/main" id="{DD8E68C9-F981-ACBA-B247-609BB534CDA3}"/>
+          <p:cNvPr id="3" name="TextBox 2">
+            <a:extLst>
+              <a:ext uri="{FF2B5EF4-FFF2-40B4-BE49-F238E27FC236}">
+                <a16:creationId xmlns:a16="http://schemas.microsoft.com/office/drawing/2014/main" id="{030CEB7B-0657-92D3-153F-75C84AB30291}"/>
               </a:ext>
             </a:extLst>
           </p:cNvPr>
@@ -4501,8 +4117,8 @@
         </p:nvSpPr>
         <p:spPr>
           <a:xfrm>
-            <a:off x="6546574" y="507788"/>
-            <a:ext cx="6096000" cy="1200329"/>
+            <a:off x="0" y="1537013"/>
+            <a:ext cx="4159690" cy="369332"/>
           </a:xfrm>
           <a:prstGeom prst="rect">
             <a:avLst/>
@@ -4516,72 +4132,458 @@
           <a:lstStyle/>
           <a:p>
             <a:r>
-              <a:rPr lang="en-AU" b="1" i="0" dirty="0">
-                <a:effectLst/>
-                <a:highlight>
-                  <a:srgbClr val="FFFFFF"/>
-                </a:highlight>
-                <a:latin typeface="-apple-system"/>
+              <a:rPr lang="en-US" sz="1800" dirty="0"/>
+              <a:t>business decisions</a:t>
+            </a:r>
+            <a:endParaRPr lang="en-US" dirty="0"/>
+          </a:p>
+        </p:txBody>
+      </p:sp>
+      <p:sp>
+        <p:nvSpPr>
+          <p:cNvPr id="5" name="Rectangle 4">
+            <a:extLst>
+              <a:ext uri="{FF2B5EF4-FFF2-40B4-BE49-F238E27FC236}">
+                <a16:creationId xmlns:a16="http://schemas.microsoft.com/office/drawing/2014/main" id="{0AF6A817-DFA8-CB18-988F-D8E7A68A5A03}"/>
+              </a:ext>
+            </a:extLst>
+          </p:cNvPr>
+          <p:cNvSpPr/>
+          <p:nvPr/>
+        </p:nvSpPr>
+        <p:spPr>
+          <a:xfrm>
+            <a:off x="6096002" y="6145503"/>
+            <a:ext cx="1583775" cy="503582"/>
+          </a:xfrm>
+          <a:prstGeom prst="rect">
+            <a:avLst/>
+          </a:prstGeom>
+          <a:solidFill>
+            <a:schemeClr val="tx2">
+              <a:lumMod val="25000"/>
+              <a:lumOff val="75000"/>
+            </a:schemeClr>
+          </a:solidFill>
+          <a:ln>
+            <a:solidFill>
+              <a:srgbClr val="0070C0"/>
+            </a:solidFill>
+          </a:ln>
+        </p:spPr>
+        <p:style>
+          <a:lnRef idx="2">
+            <a:schemeClr val="accent1">
+              <a:shade val="15000"/>
+            </a:schemeClr>
+          </a:lnRef>
+          <a:fillRef idx="1">
+            <a:schemeClr val="accent1"/>
+          </a:fillRef>
+          <a:effectRef idx="0">
+            <a:schemeClr val="accent1"/>
+          </a:effectRef>
+          <a:fontRef idx="minor">
+            <a:schemeClr val="lt1"/>
+          </a:fontRef>
+        </p:style>
+        <p:txBody>
+          <a:bodyPr rtlCol="0" anchor="ctr"/>
+          <a:lstStyle/>
+          <a:p>
+            <a:pPr algn="ctr"/>
+            <a:r>
+              <a:rPr lang="en-US" sz="1800" dirty="0">
+                <a:solidFill>
+                  <a:schemeClr val="tx1"/>
+                </a:solidFill>
               </a:rPr>
-              <a:t>Capability:</a:t>
-            </a:r>
-            <a:r>
-              <a:rPr lang="en-AU" b="0" i="0" dirty="0">
-                <a:effectLst/>
-                <a:highlight>
-                  <a:srgbClr val="FFFFFF"/>
-                </a:highlight>
-                <a:latin typeface="-apple-system"/>
+              <a:t>Infrastructure Layer</a:t>
+            </a:r>
+          </a:p>
+        </p:txBody>
+      </p:sp>
+      <p:sp>
+        <p:nvSpPr>
+          <p:cNvPr id="10" name="Rectangle 9">
+            <a:extLst>
+              <a:ext uri="{FF2B5EF4-FFF2-40B4-BE49-F238E27FC236}">
+                <a16:creationId xmlns:a16="http://schemas.microsoft.com/office/drawing/2014/main" id="{74E49286-F314-269E-1A4C-4F044EDDB547}"/>
+              </a:ext>
+            </a:extLst>
+          </p:cNvPr>
+          <p:cNvSpPr/>
+          <p:nvPr/>
+        </p:nvSpPr>
+        <p:spPr>
+          <a:xfrm>
+            <a:off x="6096002" y="5490075"/>
+            <a:ext cx="1583775" cy="503582"/>
+          </a:xfrm>
+          <a:prstGeom prst="rect">
+            <a:avLst/>
+          </a:prstGeom>
+          <a:solidFill>
+            <a:schemeClr val="tx2">
+              <a:lumMod val="25000"/>
+              <a:lumOff val="75000"/>
+            </a:schemeClr>
+          </a:solidFill>
+          <a:ln>
+            <a:solidFill>
+              <a:srgbClr val="0070C0"/>
+            </a:solidFill>
+          </a:ln>
+        </p:spPr>
+        <p:style>
+          <a:lnRef idx="2">
+            <a:schemeClr val="accent1">
+              <a:shade val="15000"/>
+            </a:schemeClr>
+          </a:lnRef>
+          <a:fillRef idx="1">
+            <a:schemeClr val="accent1"/>
+          </a:fillRef>
+          <a:effectRef idx="0">
+            <a:schemeClr val="accent1"/>
+          </a:effectRef>
+          <a:fontRef idx="minor">
+            <a:schemeClr val="lt1"/>
+          </a:fontRef>
+        </p:style>
+        <p:txBody>
+          <a:bodyPr rtlCol="0" anchor="ctr"/>
+          <a:lstStyle/>
+          <a:p>
+            <a:pPr algn="ctr"/>
+            <a:r>
+              <a:rPr lang="en-US" sz="1800" dirty="0">
+                <a:solidFill>
+                  <a:schemeClr val="tx1"/>
+                </a:solidFill>
               </a:rPr>
-              <a:t> is the what we do</a:t>
-            </a:r>
-            <a:br>
-              <a:rPr lang="en-AU" dirty="0"/>
-            </a:br>
-            <a:r>
-              <a:rPr lang="en-AU" b="1" i="0" dirty="0">
-                <a:effectLst/>
-                <a:highlight>
-                  <a:srgbClr val="FFFFFF"/>
-                </a:highlight>
-                <a:latin typeface="-apple-system"/>
+              <a:t>Runtime Layer</a:t>
+            </a:r>
+          </a:p>
+        </p:txBody>
+      </p:sp>
+      <p:sp>
+        <p:nvSpPr>
+          <p:cNvPr id="23" name="Rectangle 22">
+            <a:extLst>
+              <a:ext uri="{FF2B5EF4-FFF2-40B4-BE49-F238E27FC236}">
+                <a16:creationId xmlns:a16="http://schemas.microsoft.com/office/drawing/2014/main" id="{9EE1857D-408C-7833-3282-7C7C91FA8C67}"/>
+              </a:ext>
+            </a:extLst>
+          </p:cNvPr>
+          <p:cNvSpPr/>
+          <p:nvPr/>
+        </p:nvSpPr>
+        <p:spPr>
+          <a:xfrm>
+            <a:off x="6096000" y="4846307"/>
+            <a:ext cx="1583775" cy="503582"/>
+          </a:xfrm>
+          <a:prstGeom prst="rect">
+            <a:avLst/>
+          </a:prstGeom>
+          <a:solidFill>
+            <a:schemeClr val="tx2">
+              <a:lumMod val="25000"/>
+              <a:lumOff val="75000"/>
+            </a:schemeClr>
+          </a:solidFill>
+          <a:ln>
+            <a:solidFill>
+              <a:srgbClr val="0070C0"/>
+            </a:solidFill>
+          </a:ln>
+        </p:spPr>
+        <p:style>
+          <a:lnRef idx="2">
+            <a:schemeClr val="accent1">
+              <a:shade val="15000"/>
+            </a:schemeClr>
+          </a:lnRef>
+          <a:fillRef idx="1">
+            <a:schemeClr val="accent1"/>
+          </a:fillRef>
+          <a:effectRef idx="0">
+            <a:schemeClr val="accent1"/>
+          </a:effectRef>
+          <a:fontRef idx="minor">
+            <a:schemeClr val="lt1"/>
+          </a:fontRef>
+        </p:style>
+        <p:txBody>
+          <a:bodyPr rtlCol="0" anchor="ctr"/>
+          <a:lstStyle/>
+          <a:p>
+            <a:pPr algn="ctr"/>
+            <a:r>
+              <a:rPr lang="en-US" sz="1800" dirty="0">
+                <a:solidFill>
+                  <a:schemeClr val="tx1"/>
+                </a:solidFill>
               </a:rPr>
-              <a:t>Process:</a:t>
-            </a:r>
-            <a:r>
-              <a:rPr lang="en-AU" b="0" i="0" dirty="0">
-                <a:effectLst/>
-                <a:highlight>
-                  <a:srgbClr val="FFFFFF"/>
-                </a:highlight>
-                <a:latin typeface="-apple-system"/>
+              <a:t>Library Layer</a:t>
+            </a:r>
+          </a:p>
+        </p:txBody>
+      </p:sp>
+      <p:sp>
+        <p:nvSpPr>
+          <p:cNvPr id="24" name="Rectangle 23">
+            <a:extLst>
+              <a:ext uri="{FF2B5EF4-FFF2-40B4-BE49-F238E27FC236}">
+                <a16:creationId xmlns:a16="http://schemas.microsoft.com/office/drawing/2014/main" id="{A5861274-0206-17B1-23CD-62BA7FE63D8F}"/>
+              </a:ext>
+            </a:extLst>
+          </p:cNvPr>
+          <p:cNvSpPr/>
+          <p:nvPr/>
+        </p:nvSpPr>
+        <p:spPr>
+          <a:xfrm>
+            <a:off x="6112724" y="4211686"/>
+            <a:ext cx="1583775" cy="503582"/>
+          </a:xfrm>
+          <a:prstGeom prst="rect">
+            <a:avLst/>
+          </a:prstGeom>
+          <a:solidFill>
+            <a:schemeClr val="tx2">
+              <a:lumMod val="25000"/>
+              <a:lumOff val="75000"/>
+            </a:schemeClr>
+          </a:solidFill>
+          <a:ln>
+            <a:solidFill>
+              <a:srgbClr val="0070C0"/>
+            </a:solidFill>
+          </a:ln>
+        </p:spPr>
+        <p:style>
+          <a:lnRef idx="2">
+            <a:schemeClr val="accent1">
+              <a:shade val="15000"/>
+            </a:schemeClr>
+          </a:lnRef>
+          <a:fillRef idx="1">
+            <a:schemeClr val="accent1"/>
+          </a:fillRef>
+          <a:effectRef idx="0">
+            <a:schemeClr val="accent1"/>
+          </a:effectRef>
+          <a:fontRef idx="minor">
+            <a:schemeClr val="lt1"/>
+          </a:fontRef>
+        </p:style>
+        <p:txBody>
+          <a:bodyPr rtlCol="0" anchor="ctr"/>
+          <a:lstStyle/>
+          <a:p>
+            <a:pPr algn="ctr"/>
+            <a:r>
+              <a:rPr lang="en-US" sz="1800" dirty="0">
+                <a:solidFill>
+                  <a:schemeClr val="tx1"/>
+                </a:solidFill>
               </a:rPr>
-              <a:t> is the how we do it (--&gt; how a capability is executed)</a:t>
-            </a:r>
-            <a:br>
-              <a:rPr lang="en-AU" dirty="0"/>
-            </a:br>
-            <a:r>
-              <a:rPr lang="en-AU" b="1" i="0" dirty="0">
-                <a:effectLst/>
-                <a:highlight>
-                  <a:srgbClr val="FFFFFF"/>
-                </a:highlight>
-                <a:latin typeface="-apple-system"/>
+              <a:t>Domain Layer</a:t>
+            </a:r>
+          </a:p>
+        </p:txBody>
+      </p:sp>
+      <p:sp>
+        <p:nvSpPr>
+          <p:cNvPr id="29" name="Rectangle 28">
+            <a:extLst>
+              <a:ext uri="{FF2B5EF4-FFF2-40B4-BE49-F238E27FC236}">
+                <a16:creationId xmlns:a16="http://schemas.microsoft.com/office/drawing/2014/main" id="{1164BC71-D279-8662-A514-8F23D2C43846}"/>
+              </a:ext>
+            </a:extLst>
+          </p:cNvPr>
+          <p:cNvSpPr/>
+          <p:nvPr/>
+        </p:nvSpPr>
+        <p:spPr>
+          <a:xfrm>
+            <a:off x="6115712" y="3567918"/>
+            <a:ext cx="1583775" cy="503582"/>
+          </a:xfrm>
+          <a:prstGeom prst="rect">
+            <a:avLst/>
+          </a:prstGeom>
+          <a:solidFill>
+            <a:schemeClr val="tx2">
+              <a:lumMod val="25000"/>
+              <a:lumOff val="75000"/>
+            </a:schemeClr>
+          </a:solidFill>
+          <a:ln>
+            <a:solidFill>
+              <a:srgbClr val="0070C0"/>
+            </a:solidFill>
+          </a:ln>
+        </p:spPr>
+        <p:style>
+          <a:lnRef idx="2">
+            <a:schemeClr val="accent1">
+              <a:shade val="15000"/>
+            </a:schemeClr>
+          </a:lnRef>
+          <a:fillRef idx="1">
+            <a:schemeClr val="accent1"/>
+          </a:fillRef>
+          <a:effectRef idx="0">
+            <a:schemeClr val="accent1"/>
+          </a:effectRef>
+          <a:fontRef idx="minor">
+            <a:schemeClr val="lt1"/>
+          </a:fontRef>
+        </p:style>
+        <p:txBody>
+          <a:bodyPr rtlCol="0" anchor="ctr"/>
+          <a:lstStyle/>
+          <a:p>
+            <a:pPr algn="ctr"/>
+            <a:r>
+              <a:rPr lang="en-US" sz="1800" dirty="0">
+                <a:solidFill>
+                  <a:schemeClr val="tx1"/>
+                </a:solidFill>
               </a:rPr>
-              <a:t>Service:</a:t>
-            </a:r>
-            <a:r>
-              <a:rPr lang="en-AU" b="0" i="0" dirty="0">
-                <a:effectLst/>
-                <a:highlight>
-                  <a:srgbClr val="FFFFFF"/>
-                </a:highlight>
-                <a:latin typeface="-apple-system"/>
+              <a:t>Interface Layer</a:t>
+            </a:r>
+          </a:p>
+        </p:txBody>
+      </p:sp>
+      <p:sp>
+        <p:nvSpPr>
+          <p:cNvPr id="30" name="Rectangle 29">
+            <a:extLst>
+              <a:ext uri="{FF2B5EF4-FFF2-40B4-BE49-F238E27FC236}">
+                <a16:creationId xmlns:a16="http://schemas.microsoft.com/office/drawing/2014/main" id="{0C36C7AA-7A31-5098-5633-18E824484E10}"/>
+              </a:ext>
+            </a:extLst>
+          </p:cNvPr>
+          <p:cNvSpPr/>
+          <p:nvPr/>
+        </p:nvSpPr>
+        <p:spPr>
+          <a:xfrm>
+            <a:off x="6115711" y="2933297"/>
+            <a:ext cx="1583775" cy="503582"/>
+          </a:xfrm>
+          <a:prstGeom prst="rect">
+            <a:avLst/>
+          </a:prstGeom>
+          <a:solidFill>
+            <a:schemeClr val="tx2">
+              <a:lumMod val="25000"/>
+              <a:lumOff val="75000"/>
+            </a:schemeClr>
+          </a:solidFill>
+          <a:ln>
+            <a:solidFill>
+              <a:srgbClr val="0070C0"/>
+            </a:solidFill>
+          </a:ln>
+        </p:spPr>
+        <p:style>
+          <a:lnRef idx="2">
+            <a:schemeClr val="accent1">
+              <a:shade val="15000"/>
+            </a:schemeClr>
+          </a:lnRef>
+          <a:fillRef idx="1">
+            <a:schemeClr val="accent1"/>
+          </a:fillRef>
+          <a:effectRef idx="0">
+            <a:schemeClr val="accent1"/>
+          </a:effectRef>
+          <a:fontRef idx="minor">
+            <a:schemeClr val="lt1"/>
+          </a:fontRef>
+        </p:style>
+        <p:txBody>
+          <a:bodyPr rtlCol="0" anchor="ctr"/>
+          <a:lstStyle/>
+          <a:p>
+            <a:pPr algn="ctr"/>
+            <a:r>
+              <a:rPr lang="en-US" sz="1800" dirty="0">
+                <a:solidFill>
+                  <a:schemeClr val="tx1"/>
+                </a:solidFill>
               </a:rPr>
-              <a:t> is the how we access it (--&gt; how a capability is accessed)</a:t>
-            </a:r>
-            <a:endParaRPr lang="en-US" dirty="0"/>
+              <a:t>Protocol Layer</a:t>
+            </a:r>
+          </a:p>
+        </p:txBody>
+      </p:sp>
+      <p:sp>
+        <p:nvSpPr>
+          <p:cNvPr id="31" name="Rectangle 30">
+            <a:extLst>
+              <a:ext uri="{FF2B5EF4-FFF2-40B4-BE49-F238E27FC236}">
+                <a16:creationId xmlns:a16="http://schemas.microsoft.com/office/drawing/2014/main" id="{E53CB342-F917-A8C6-910B-2D0E76B3DF80}"/>
+              </a:ext>
+            </a:extLst>
+          </p:cNvPr>
+          <p:cNvSpPr/>
+          <p:nvPr/>
+        </p:nvSpPr>
+        <p:spPr>
+          <a:xfrm>
+            <a:off x="6115711" y="2298676"/>
+            <a:ext cx="1583775" cy="503582"/>
+          </a:xfrm>
+          <a:prstGeom prst="rect">
+            <a:avLst/>
+          </a:prstGeom>
+          <a:solidFill>
+            <a:schemeClr val="tx2">
+              <a:lumMod val="25000"/>
+              <a:lumOff val="75000"/>
+            </a:schemeClr>
+          </a:solidFill>
+          <a:ln>
+            <a:solidFill>
+              <a:srgbClr val="0070C0"/>
+            </a:solidFill>
+          </a:ln>
+        </p:spPr>
+        <p:style>
+          <a:lnRef idx="2">
+            <a:schemeClr val="accent1">
+              <a:shade val="15000"/>
+            </a:schemeClr>
+          </a:lnRef>
+          <a:fillRef idx="1">
+            <a:schemeClr val="accent1"/>
+          </a:fillRef>
+          <a:effectRef idx="0">
+            <a:schemeClr val="accent1"/>
+          </a:effectRef>
+          <a:fontRef idx="minor">
+            <a:schemeClr val="lt1"/>
+          </a:fontRef>
+        </p:style>
+        <p:txBody>
+          <a:bodyPr rtlCol="0" anchor="ctr"/>
+          <a:lstStyle/>
+          <a:p>
+            <a:pPr algn="ctr"/>
+            <a:r>
+              <a:rPr lang="en-US" sz="1800" dirty="0">
+                <a:solidFill>
+                  <a:schemeClr val="tx1"/>
+                </a:solidFill>
+              </a:rPr>
+              <a:t>External Layer</a:t>
+            </a:r>
           </a:p>
         </p:txBody>
       </p:sp>
@@ -4617,10 +4619,255 @@
       </p:grpSpPr>
       <p:sp>
         <p:nvSpPr>
-          <p:cNvPr id="4" name="Oval 3">
-            <a:extLst>
-              <a:ext uri="{FF2B5EF4-FFF2-40B4-BE49-F238E27FC236}">
-                <a16:creationId xmlns:a16="http://schemas.microsoft.com/office/drawing/2014/main" id="{E361F9B7-CC3E-25D1-00EC-C23ECEE687EF}"/>
+          <p:cNvPr id="4" name="TextBox 3">
+            <a:extLst>
+              <a:ext uri="{FF2B5EF4-FFF2-40B4-BE49-F238E27FC236}">
+                <a16:creationId xmlns:a16="http://schemas.microsoft.com/office/drawing/2014/main" id="{93A7D7C9-7BC3-DFF0-7357-A6678B6E88D9}"/>
+              </a:ext>
+            </a:extLst>
+          </p:cNvPr>
+          <p:cNvSpPr txBox="1"/>
+          <p:nvPr/>
+        </p:nvSpPr>
+        <p:spPr>
+          <a:xfrm>
+            <a:off x="3342322" y="1250028"/>
+            <a:ext cx="803425" cy="307777"/>
+          </a:xfrm>
+          <a:prstGeom prst="rect">
+            <a:avLst/>
+          </a:prstGeom>
+          <a:noFill/>
+        </p:spPr>
+        <p:txBody>
+          <a:bodyPr wrap="square" rtlCol="0">
+            <a:spAutoFit/>
+          </a:bodyPr>
+          <a:lstStyle/>
+          <a:p>
+            <a:r>
+              <a:rPr lang="en-US" sz="1400" dirty="0"/>
+              <a:t>security</a:t>
+            </a:r>
+          </a:p>
+        </p:txBody>
+      </p:sp>
+      <p:sp>
+        <p:nvSpPr>
+          <p:cNvPr id="5" name="TextBox 4">
+            <a:extLst>
+              <a:ext uri="{FF2B5EF4-FFF2-40B4-BE49-F238E27FC236}">
+                <a16:creationId xmlns:a16="http://schemas.microsoft.com/office/drawing/2014/main" id="{AFBAB54D-CCA4-36A0-2A38-3615F5DFFB28}"/>
+              </a:ext>
+            </a:extLst>
+          </p:cNvPr>
+          <p:cNvSpPr txBox="1"/>
+          <p:nvPr/>
+        </p:nvSpPr>
+        <p:spPr>
+          <a:xfrm>
+            <a:off x="2235856" y="1831117"/>
+            <a:ext cx="2216706" cy="523220"/>
+          </a:xfrm>
+          <a:prstGeom prst="rect">
+            <a:avLst/>
+          </a:prstGeom>
+          <a:noFill/>
+        </p:spPr>
+        <p:txBody>
+          <a:bodyPr wrap="square" rtlCol="0">
+            <a:spAutoFit/>
+          </a:bodyPr>
+          <a:lstStyle/>
+          <a:p>
+            <a:r>
+              <a:rPr lang="en-US" sz="1400" dirty="0"/>
+              <a:t>Secure the protocol layer, in HTTP, correct headers,</a:t>
+            </a:r>
+          </a:p>
+        </p:txBody>
+      </p:sp>
+      <p:sp>
+        <p:nvSpPr>
+          <p:cNvPr id="6" name="TextBox 5">
+            <a:extLst>
+              <a:ext uri="{FF2B5EF4-FFF2-40B4-BE49-F238E27FC236}">
+                <a16:creationId xmlns:a16="http://schemas.microsoft.com/office/drawing/2014/main" id="{FACB8D56-8A35-2031-1CAF-F26D27F576EF}"/>
+              </a:ext>
+            </a:extLst>
+          </p:cNvPr>
+          <p:cNvSpPr txBox="1"/>
+          <p:nvPr/>
+        </p:nvSpPr>
+        <p:spPr>
+          <a:xfrm>
+            <a:off x="2232082" y="2521477"/>
+            <a:ext cx="2220480" cy="307777"/>
+          </a:xfrm>
+          <a:prstGeom prst="rect">
+            <a:avLst/>
+          </a:prstGeom>
+          <a:noFill/>
+        </p:spPr>
+        <p:txBody>
+          <a:bodyPr wrap="square" rtlCol="0">
+            <a:spAutoFit/>
+          </a:bodyPr>
+          <a:lstStyle/>
+          <a:p>
+            <a:r>
+              <a:rPr lang="en-US" sz="1400" dirty="0"/>
+              <a:t>Business permission rules</a:t>
+            </a:r>
+          </a:p>
+        </p:txBody>
+      </p:sp>
+      <p:sp>
+        <p:nvSpPr>
+          <p:cNvPr id="7" name="TextBox 6">
+            <a:extLst>
+              <a:ext uri="{FF2B5EF4-FFF2-40B4-BE49-F238E27FC236}">
+                <a16:creationId xmlns:a16="http://schemas.microsoft.com/office/drawing/2014/main" id="{0FDFF613-2DF4-0BEF-7FE4-5783322686DF}"/>
+              </a:ext>
+            </a:extLst>
+          </p:cNvPr>
+          <p:cNvSpPr txBox="1"/>
+          <p:nvPr/>
+        </p:nvSpPr>
+        <p:spPr>
+          <a:xfrm>
+            <a:off x="2314447" y="3341970"/>
+            <a:ext cx="2220480" cy="307777"/>
+          </a:xfrm>
+          <a:prstGeom prst="rect">
+            <a:avLst/>
+          </a:prstGeom>
+          <a:noFill/>
+        </p:spPr>
+        <p:txBody>
+          <a:bodyPr wrap="square" rtlCol="0">
+            <a:spAutoFit/>
+          </a:bodyPr>
+          <a:lstStyle/>
+          <a:p>
+            <a:r>
+              <a:rPr lang="en-US" sz="1400" dirty="0"/>
+              <a:t>Business permission rules</a:t>
+            </a:r>
+          </a:p>
+        </p:txBody>
+      </p:sp>
+      <p:sp>
+        <p:nvSpPr>
+          <p:cNvPr id="8" name="TextBox 7">
+            <a:extLst>
+              <a:ext uri="{FF2B5EF4-FFF2-40B4-BE49-F238E27FC236}">
+                <a16:creationId xmlns:a16="http://schemas.microsoft.com/office/drawing/2014/main" id="{9AB8CA1B-0212-6F25-DFF5-439466575512}"/>
+              </a:ext>
+            </a:extLst>
+          </p:cNvPr>
+          <p:cNvSpPr txBox="1"/>
+          <p:nvPr/>
+        </p:nvSpPr>
+        <p:spPr>
+          <a:xfrm>
+            <a:off x="2304969" y="4470242"/>
+            <a:ext cx="1851148" cy="307777"/>
+          </a:xfrm>
+          <a:prstGeom prst="rect">
+            <a:avLst/>
+          </a:prstGeom>
+          <a:noFill/>
+        </p:spPr>
+        <p:txBody>
+          <a:bodyPr wrap="square" rtlCol="0">
+            <a:spAutoFit/>
+          </a:bodyPr>
+          <a:lstStyle/>
+          <a:p>
+            <a:r>
+              <a:rPr lang="en-US" sz="1400" dirty="0"/>
+              <a:t>Keep Java Up-to-Date</a:t>
+            </a:r>
+          </a:p>
+        </p:txBody>
+      </p:sp>
+      <p:sp>
+        <p:nvSpPr>
+          <p:cNvPr id="9" name="TextBox 8">
+            <a:extLst>
+              <a:ext uri="{FF2B5EF4-FFF2-40B4-BE49-F238E27FC236}">
+                <a16:creationId xmlns:a16="http://schemas.microsoft.com/office/drawing/2014/main" id="{54B73081-BD3A-8594-BB21-F0862E8E0722}"/>
+              </a:ext>
+            </a:extLst>
+          </p:cNvPr>
+          <p:cNvSpPr txBox="1"/>
+          <p:nvPr/>
+        </p:nvSpPr>
+        <p:spPr>
+          <a:xfrm>
+            <a:off x="2364604" y="3894234"/>
+            <a:ext cx="1960921" cy="307777"/>
+          </a:xfrm>
+          <a:prstGeom prst="rect">
+            <a:avLst/>
+          </a:prstGeom>
+          <a:noFill/>
+        </p:spPr>
+        <p:txBody>
+          <a:bodyPr wrap="square" rtlCol="0">
+            <a:spAutoFit/>
+          </a:bodyPr>
+          <a:lstStyle/>
+          <a:p>
+            <a:r>
+              <a:rPr lang="en-US" sz="1400" dirty="0"/>
+              <a:t>Dependency Scanning</a:t>
+            </a:r>
+          </a:p>
+        </p:txBody>
+      </p:sp>
+      <p:sp>
+        <p:nvSpPr>
+          <p:cNvPr id="10" name="TextBox 9">
+            <a:extLst>
+              <a:ext uri="{FF2B5EF4-FFF2-40B4-BE49-F238E27FC236}">
+                <a16:creationId xmlns:a16="http://schemas.microsoft.com/office/drawing/2014/main" id="{F1CA063A-4C29-D091-911B-E8EF988B2C5C}"/>
+              </a:ext>
+            </a:extLst>
+          </p:cNvPr>
+          <p:cNvSpPr txBox="1"/>
+          <p:nvPr/>
+        </p:nvSpPr>
+        <p:spPr>
+          <a:xfrm>
+            <a:off x="2232082" y="5046250"/>
+            <a:ext cx="1327608" cy="307777"/>
+          </a:xfrm>
+          <a:prstGeom prst="rect">
+            <a:avLst/>
+          </a:prstGeom>
+          <a:noFill/>
+        </p:spPr>
+        <p:txBody>
+          <a:bodyPr wrap="square" rtlCol="0">
+            <a:spAutoFit/>
+          </a:bodyPr>
+          <a:lstStyle/>
+          <a:p>
+            <a:r>
+              <a:rPr lang="en-US" sz="1400" dirty="0"/>
+              <a:t>Cloud Security</a:t>
+            </a:r>
+          </a:p>
+        </p:txBody>
+      </p:sp>
+      <p:sp>
+        <p:nvSpPr>
+          <p:cNvPr id="11" name="Rectangle 10">
+            <a:extLst>
+              <a:ext uri="{FF2B5EF4-FFF2-40B4-BE49-F238E27FC236}">
+                <a16:creationId xmlns:a16="http://schemas.microsoft.com/office/drawing/2014/main" id="{D8923E95-F99D-02A3-7BE6-40980B92F9AC}"/>
               </a:ext>
             </a:extLst>
           </p:cNvPr>
@@ -4629,13 +4876,12 @@
         </p:nvSpPr>
         <p:spPr>
           <a:xfrm>
-            <a:off x="3281075" y="1203222"/>
-            <a:ext cx="1742302" cy="1742302"/>
-          </a:xfrm>
-          <a:prstGeom prst="ellipse">
-            <a:avLst/>
-          </a:prstGeom>
-          <a:noFill/>
+            <a:off x="5317434" y="2054908"/>
+            <a:ext cx="2458280" cy="1839326"/>
+          </a:xfrm>
+          <a:prstGeom prst="rect">
+            <a:avLst/>
+          </a:prstGeom>
         </p:spPr>
         <p:style>
           <a:lnRef idx="2">
@@ -4658,20 +4904,147 @@
           <a:lstStyle/>
           <a:p>
             <a:pPr algn="ctr"/>
-            <a:endParaRPr lang="en-US" sz="1400" dirty="0">
-              <a:solidFill>
-                <a:schemeClr val="tx1"/>
-              </a:solidFill>
-            </a:endParaRPr>
-          </a:p>
-        </p:txBody>
-      </p:sp>
-      <p:sp>
-        <p:nvSpPr>
-          <p:cNvPr id="5" name="Oval 4">
-            <a:extLst>
-              <a:ext uri="{FF2B5EF4-FFF2-40B4-BE49-F238E27FC236}">
-                <a16:creationId xmlns:a16="http://schemas.microsoft.com/office/drawing/2014/main" id="{527497EE-DF28-8FA2-2780-4C38AF28EBC8}"/>
+            <a:r>
+              <a:rPr lang="en-US" dirty="0"/>
+              <a:t>code scanning</a:t>
+            </a:r>
+          </a:p>
+        </p:txBody>
+      </p:sp>
+      <p:sp>
+        <p:nvSpPr>
+          <p:cNvPr id="12" name="TextBox 11">
+            <a:extLst>
+              <a:ext uri="{FF2B5EF4-FFF2-40B4-BE49-F238E27FC236}">
+                <a16:creationId xmlns:a16="http://schemas.microsoft.com/office/drawing/2014/main" id="{330A78D0-69B7-DCD1-7F6F-E0FEB8D5B899}"/>
+              </a:ext>
+            </a:extLst>
+          </p:cNvPr>
+          <p:cNvSpPr txBox="1"/>
+          <p:nvPr/>
+        </p:nvSpPr>
+        <p:spPr>
+          <a:xfrm>
+            <a:off x="5729451" y="449422"/>
+            <a:ext cx="6096000" cy="1200329"/>
+          </a:xfrm>
+          <a:prstGeom prst="rect">
+            <a:avLst/>
+          </a:prstGeom>
+          <a:noFill/>
+        </p:spPr>
+        <p:txBody>
+          <a:bodyPr wrap="square">
+            <a:spAutoFit/>
+          </a:bodyPr>
+          <a:lstStyle/>
+          <a:p>
+            <a:r>
+              <a:rPr lang="en-AU" b="1" i="0" dirty="0">
+                <a:effectLst/>
+                <a:highlight>
+                  <a:srgbClr val="FFFFFF"/>
+                </a:highlight>
+                <a:latin typeface="-apple-system"/>
+              </a:rPr>
+              <a:t>Capability:</a:t>
+            </a:r>
+            <a:r>
+              <a:rPr lang="en-AU" b="0" i="0" dirty="0">
+                <a:effectLst/>
+                <a:highlight>
+                  <a:srgbClr val="FFFFFF"/>
+                </a:highlight>
+                <a:latin typeface="-apple-system"/>
+              </a:rPr>
+              <a:t> is the what we do</a:t>
+            </a:r>
+            <a:br>
+              <a:rPr lang="en-AU" dirty="0"/>
+            </a:br>
+            <a:r>
+              <a:rPr lang="en-AU" b="1" i="0" dirty="0">
+                <a:effectLst/>
+                <a:highlight>
+                  <a:srgbClr val="FFFFFF"/>
+                </a:highlight>
+                <a:latin typeface="-apple-system"/>
+              </a:rPr>
+              <a:t>Process:</a:t>
+            </a:r>
+            <a:r>
+              <a:rPr lang="en-AU" b="0" i="0" dirty="0">
+                <a:effectLst/>
+                <a:highlight>
+                  <a:srgbClr val="FFFFFF"/>
+                </a:highlight>
+                <a:latin typeface="-apple-system"/>
+              </a:rPr>
+              <a:t> is the how we do it (--&gt; how a capability is executed)</a:t>
+            </a:r>
+            <a:br>
+              <a:rPr lang="en-AU" dirty="0"/>
+            </a:br>
+            <a:r>
+              <a:rPr lang="en-AU" b="1" i="0" dirty="0">
+                <a:effectLst/>
+                <a:highlight>
+                  <a:srgbClr val="FFFFFF"/>
+                </a:highlight>
+                <a:latin typeface="-apple-system"/>
+              </a:rPr>
+              <a:t>Service:</a:t>
+            </a:r>
+            <a:r>
+              <a:rPr lang="en-AU" b="0" i="0" dirty="0">
+                <a:effectLst/>
+                <a:highlight>
+                  <a:srgbClr val="FFFFFF"/>
+                </a:highlight>
+                <a:latin typeface="-apple-system"/>
+              </a:rPr>
+              <a:t> is the how we access it (--&gt; how a capability is accessed)</a:t>
+            </a:r>
+            <a:endParaRPr lang="en-US" dirty="0"/>
+          </a:p>
+        </p:txBody>
+      </p:sp>
+    </p:spTree>
+    <p:extLst>
+      <p:ext uri="{BB962C8B-B14F-4D97-AF65-F5344CB8AC3E}">
+        <p14:creationId xmlns:p14="http://schemas.microsoft.com/office/powerpoint/2010/main" val="2680460071"/>
+      </p:ext>
+    </p:extLst>
+  </p:cSld>
+  <p:clrMapOvr>
+    <a:masterClrMapping/>
+  </p:clrMapOvr>
+</p:sld>
+</file>
+
+<file path=ppt/slides/slide3.xml><?xml version="1.0" encoding="utf-8"?>
+<p:sld xmlns:a="http://schemas.openxmlformats.org/drawingml/2006/main" xmlns:r="http://schemas.openxmlformats.org/officeDocument/2006/relationships" xmlns:p="http://schemas.openxmlformats.org/presentationml/2006/main">
+  <p:cSld>
+    <p:spTree>
+      <p:nvGrpSpPr>
+        <p:cNvPr id="1" name=""/>
+        <p:cNvGrpSpPr/>
+        <p:nvPr/>
+      </p:nvGrpSpPr>
+      <p:grpSpPr>
+        <a:xfrm>
+          <a:off x="0" y="0"/>
+          <a:ext cx="0" cy="0"/>
+          <a:chOff x="0" y="0"/>
+          <a:chExt cx="0" cy="0"/>
+        </a:xfrm>
+      </p:grpSpPr>
+      <p:sp>
+        <p:nvSpPr>
+          <p:cNvPr id="4" name="Oval 3">
+            <a:extLst>
+              <a:ext uri="{FF2B5EF4-FFF2-40B4-BE49-F238E27FC236}">
+                <a16:creationId xmlns:a16="http://schemas.microsoft.com/office/drawing/2014/main" id="{E361F9B7-CC3E-25D1-00EC-C23ECEE687EF}"/>
               </a:ext>
             </a:extLst>
           </p:cNvPr>
@@ -4680,7 +5053,7 @@
         </p:nvSpPr>
         <p:spPr>
           <a:xfrm>
-            <a:off x="4562769" y="1203222"/>
+            <a:off x="3271347" y="2185716"/>
             <a:ext cx="1742302" cy="1742302"/>
           </a:xfrm>
           <a:prstGeom prst="ellipse">
@@ -4709,23 +5082,20 @@
           <a:lstStyle/>
           <a:p>
             <a:pPr algn="ctr"/>
-            <a:r>
-              <a:rPr lang="en-US" dirty="0">
-                <a:solidFill>
-                  <a:schemeClr val="tx1"/>
-                </a:solidFill>
-              </a:rPr>
-              <a:t>What Exists</a:t>
-            </a:r>
-          </a:p>
-        </p:txBody>
-      </p:sp>
-      <p:sp>
-        <p:nvSpPr>
-          <p:cNvPr id="6" name="Oval 5">
-            <a:extLst>
-              <a:ext uri="{FF2B5EF4-FFF2-40B4-BE49-F238E27FC236}">
-                <a16:creationId xmlns:a16="http://schemas.microsoft.com/office/drawing/2014/main" id="{D1F9AD85-E577-391A-8FB7-E93AC93F65AD}"/>
+            <a:endParaRPr lang="en-US" sz="1400" dirty="0">
+              <a:solidFill>
+                <a:schemeClr val="tx1"/>
+              </a:solidFill>
+            </a:endParaRPr>
+          </a:p>
+        </p:txBody>
+      </p:sp>
+      <p:sp>
+        <p:nvSpPr>
+          <p:cNvPr id="5" name="Oval 4">
+            <a:extLst>
+              <a:ext uri="{FF2B5EF4-FFF2-40B4-BE49-F238E27FC236}">
+                <a16:creationId xmlns:a16="http://schemas.microsoft.com/office/drawing/2014/main" id="{527497EE-DF28-8FA2-2780-4C38AF28EBC8}"/>
               </a:ext>
             </a:extLst>
           </p:cNvPr>
@@ -4734,7 +5104,7 @@
         </p:nvSpPr>
         <p:spPr>
           <a:xfrm>
-            <a:off x="3921922" y="2637885"/>
+            <a:off x="4553041" y="2185716"/>
             <a:ext cx="1742302" cy="1742302"/>
           </a:xfrm>
           <a:prstGeom prst="ellipse">
@@ -4769,6 +5139,60 @@
                   <a:schemeClr val="tx1"/>
                 </a:solidFill>
               </a:rPr>
+              <a:t>What Exists</a:t>
+            </a:r>
+          </a:p>
+        </p:txBody>
+      </p:sp>
+      <p:sp>
+        <p:nvSpPr>
+          <p:cNvPr id="6" name="Oval 5">
+            <a:extLst>
+              <a:ext uri="{FF2B5EF4-FFF2-40B4-BE49-F238E27FC236}">
+                <a16:creationId xmlns:a16="http://schemas.microsoft.com/office/drawing/2014/main" id="{D1F9AD85-E577-391A-8FB7-E93AC93F65AD}"/>
+              </a:ext>
+            </a:extLst>
+          </p:cNvPr>
+          <p:cNvSpPr/>
+          <p:nvPr/>
+        </p:nvSpPr>
+        <p:spPr>
+          <a:xfrm>
+            <a:off x="3912194" y="3620379"/>
+            <a:ext cx="1742302" cy="1742302"/>
+          </a:xfrm>
+          <a:prstGeom prst="ellipse">
+            <a:avLst/>
+          </a:prstGeom>
+          <a:noFill/>
+        </p:spPr>
+        <p:style>
+          <a:lnRef idx="2">
+            <a:schemeClr val="accent1">
+              <a:shade val="15000"/>
+            </a:schemeClr>
+          </a:lnRef>
+          <a:fillRef idx="1">
+            <a:schemeClr val="accent1"/>
+          </a:fillRef>
+          <a:effectRef idx="0">
+            <a:schemeClr val="accent1"/>
+          </a:effectRef>
+          <a:fontRef idx="minor">
+            <a:schemeClr val="lt1"/>
+          </a:fontRef>
+        </p:style>
+        <p:txBody>
+          <a:bodyPr rtlCol="0" anchor="ctr"/>
+          <a:lstStyle/>
+          <a:p>
+            <a:pPr algn="ctr"/>
+            <a:r>
+              <a:rPr lang="en-US" dirty="0">
+                <a:solidFill>
+                  <a:schemeClr val="tx1"/>
+                </a:solidFill>
+              </a:rPr>
               <a:t>What we will Build</a:t>
             </a:r>
           </a:p>
@@ -4788,7 +5212,7 @@
         </p:nvSpPr>
         <p:spPr>
           <a:xfrm>
-            <a:off x="3231648" y="1781985"/>
+            <a:off x="3221920" y="2764479"/>
             <a:ext cx="1408102" cy="584775"/>
           </a:xfrm>
           <a:prstGeom prst="rect">
@@ -4838,7 +5262,7 @@
 </p:sld>
 </file>
 
-<file path=ppt/slides/slide3.xml><?xml version="1.0" encoding="utf-8"?>
+<file path=ppt/slides/slide4.xml><?xml version="1.0" encoding="utf-8"?>
 <p:sld xmlns:a="http://schemas.openxmlformats.org/drawingml/2006/main" xmlns:r="http://schemas.openxmlformats.org/officeDocument/2006/relationships" xmlns:p="http://schemas.openxmlformats.org/presentationml/2006/main">
   <p:cSld>
     <p:spTree>
@@ -5230,7 +5654,7 @@
 </p:sld>
 </file>
 
-<file path=ppt/slides/slide4.xml><?xml version="1.0" encoding="utf-8"?>
+<file path=ppt/slides/slide5.xml><?xml version="1.0" encoding="utf-8"?>
 <p:sld xmlns:a="http://schemas.openxmlformats.org/drawingml/2006/main" xmlns:r="http://schemas.openxmlformats.org/officeDocument/2006/relationships" xmlns:p="http://schemas.openxmlformats.org/presentationml/2006/main">
   <p:cSld>
     <p:spTree>

</xml_diff>